<commit_message>
Update presentation deck: First Year Project, Team Leader Muhammad Sambhyana, and all 8 team members
</commit_message>
<xml_diff>
--- a/PPT_GTU_Alert_System_Presentation.pptx
+++ b/PPT_GTU_Alert_System_Presentation.pptx
@@ -3256,7 +3256,7 @@
               </a:defRPr>
             </a:pPr>
             <a:r>
-              <a:t>FINAL YEAR CAPSTONE PROJECT DEFENSE  |  ACADEMIC PRESENTATION</a:t>
+              <a:t>FIRST YEAR PROJECT PRESENTATION  |  ACADEMIC DEFENSE</a:t>
             </a:r>
           </a:p>
         </p:txBody>
@@ -3320,7 +3320,7 @@
         <p:spPr>
           <a:xfrm>
             <a:off x="594360" y="2148840"/>
-            <a:ext cx="2578608" cy="4206240"/>
+            <a:ext cx="3931920" cy="4206240"/>
           </a:xfrm>
           <a:prstGeom prst="roundRect">
             <a:avLst/>
@@ -3365,13 +3365,13 @@
         <p:spPr>
           <a:xfrm>
             <a:off x="594360" y="2148840"/>
-            <a:ext cx="2578608" cy="475488"/>
+            <a:ext cx="3931920" cy="594360"/>
           </a:xfrm>
           <a:prstGeom prst="roundRect">
             <a:avLst/>
           </a:prstGeom>
           <a:solidFill>
-            <a:srgbClr val="1E3A8A"/>
+            <a:srgbClr val="0F2557"/>
           </a:solidFill>
           <a:ln>
             <a:noFill/>
@@ -3408,7 +3408,7 @@
         <p:spPr>
           <a:xfrm>
             <a:off x="758952" y="2194560"/>
-            <a:ext cx="2249424" cy="402336"/>
+            <a:ext cx="3602736" cy="521208"/>
           </a:xfrm>
           <a:prstGeom prst="rect">
             <a:avLst/>
@@ -3429,7 +3429,19 @@
               </a:defRPr>
             </a:pPr>
             <a:r>
-              <a:t>Project Overview</a:t>
+              <a:t>Project Leadership &amp; Details</a:t>
+            </a:r>
+          </a:p>
+          <a:p>
+            <a:pPr>
+              <a:defRPr sz="950" b="1">
+                <a:solidFill>
+                  <a:srgbClr val="E0F2FE"/>
+                </a:solidFill>
+              </a:defRPr>
+            </a:pPr>
+            <a:r>
+              <a:t>LEADERSHIP &amp; DOMAIN</a:t>
             </a:r>
           </a:p>
         </p:txBody>
@@ -3442,8 +3454,8 @@
         </p:nvSpPr>
         <p:spPr>
           <a:xfrm>
-            <a:off x="758952" y="2697480"/>
-            <a:ext cx="2249424" cy="3602736"/>
+            <a:off x="758952" y="2816352"/>
+            <a:ext cx="3602736" cy="3483864"/>
           </a:xfrm>
           <a:prstGeom prst="rect">
             <a:avLst/>
@@ -3467,7 +3479,7 @@
               </a:defRPr>
             </a:pPr>
             <a:r>
-              <a:t>•  Project Type: Full-Stack &amp; Cloud System</a:t>
+              <a:t>•  Project Scope: First Year Project</a:t>
             </a:r>
           </a:p>
           <a:p>
@@ -3482,7 +3494,7 @@
               </a:defRPr>
             </a:pPr>
             <a:r>
-              <a:t>•  Domain: University Automation &amp; NLP</a:t>
+              <a:t>•  Team Leader: Muhammad Sambhyana</a:t>
             </a:r>
           </a:p>
           <a:p>
@@ -3497,7 +3509,7 @@
               </a:defRPr>
             </a:pPr>
             <a:r>
-              <a:t>•  Focus: Student Welfare &amp; Notification AI</a:t>
+              <a:t>•  Department: Computer / IT Engineering</a:t>
             </a:r>
           </a:p>
           <a:p>
@@ -3512,6 +3524,21 @@
               </a:defRPr>
             </a:pPr>
             <a:r>
+              <a:t>•  Domain: University Automation &amp; NLP Cloud System</a:t>
+            </a:r>
+          </a:p>
+          <a:p>
+            <a:pPr>
+              <a:spcAft>
+                <a:spcPts val="900"/>
+              </a:spcAft>
+              <a:defRPr sz="1200">
+                <a:solidFill>
+                  <a:srgbClr val="0F172A"/>
+                </a:solidFill>
+              </a:defRPr>
+            </a:pPr>
+            <a:r>
               <a:t>•  Target Base: 4,00,000+ GTU Students</a:t>
             </a:r>
           </a:p>
@@ -3527,7 +3554,22 @@
               </a:defRPr>
             </a:pPr>
             <a:r>
-              <a:t>•  Coverage: 400+ Affiliated Engineering, Pharmacy &amp; Management Colleges</a:t>
+              <a:t>•  Coverage: 400+ Affiliated GTU Colleges</a:t>
+            </a:r>
+          </a:p>
+          <a:p>
+            <a:pPr>
+              <a:spcAft>
+                <a:spcPts val="900"/>
+              </a:spcAft>
+              <a:defRPr sz="1200">
+                <a:solidFill>
+                  <a:srgbClr val="0F172A"/>
+                </a:solidFill>
+              </a:defRPr>
+            </a:pPr>
+            <a:r>
+              <a:t>•  Platform: Telegram, Web PWA, Discord &amp; Voice</a:t>
             </a:r>
           </a:p>
         </p:txBody>
@@ -3540,8 +3582,8 @@
         </p:nvSpPr>
         <p:spPr>
           <a:xfrm>
-            <a:off x="3392424" y="2148840"/>
-            <a:ext cx="2578608" cy="4206240"/>
+            <a:off x="4709160" y="2148840"/>
+            <a:ext cx="3383280" cy="4206240"/>
           </a:xfrm>
           <a:prstGeom prst="roundRect">
             <a:avLst/>
@@ -3585,14 +3627,14 @@
         </p:nvSpPr>
         <p:spPr>
           <a:xfrm>
-            <a:off x="3392424" y="2148840"/>
-            <a:ext cx="2578608" cy="475488"/>
+            <a:off x="4709160" y="2148840"/>
+            <a:ext cx="3383280" cy="594360"/>
           </a:xfrm>
           <a:prstGeom prst="roundRect">
             <a:avLst/>
           </a:prstGeom>
           <a:solidFill>
-            <a:srgbClr val="0F2557"/>
+            <a:srgbClr val="1E3A8A"/>
           </a:solidFill>
           <a:ln>
             <a:noFill/>
@@ -3628,8 +3670,8 @@
         </p:nvSpPr>
         <p:spPr>
           <a:xfrm>
-            <a:off x="3557016" y="2194560"/>
-            <a:ext cx="2249424" cy="402336"/>
+            <a:off x="4873752" y="2194560"/>
+            <a:ext cx="3054096" cy="521208"/>
           </a:xfrm>
           <a:prstGeom prst="rect">
             <a:avLst/>
@@ -3650,7 +3692,19 @@
               </a:defRPr>
             </a:pPr>
             <a:r>
-              <a:t>Key Innovations</a:t>
+              <a:t>Team Members (Part 1)</a:t>
+            </a:r>
+          </a:p>
+          <a:p>
+            <a:pPr>
+              <a:defRPr sz="950" b="1">
+                <a:solidFill>
+                  <a:srgbClr val="E0F2FE"/>
+                </a:solidFill>
+              </a:defRPr>
+            </a:pPr>
+            <a:r>
+              <a:t>PROJECT TEAM MEMBERS</a:t>
             </a:r>
           </a:p>
         </p:txBody>
@@ -3663,8 +3717,8 @@
         </p:nvSpPr>
         <p:spPr>
           <a:xfrm>
-            <a:off x="3557016" y="2697480"/>
-            <a:ext cx="2249424" cy="3602736"/>
+            <a:off x="4873752" y="2816352"/>
+            <a:ext cx="3054096" cy="3483864"/>
           </a:xfrm>
           <a:prstGeom prst="rect">
             <a:avLst/>
@@ -3679,76 +3733,91 @@
           <a:p>
             <a:pPr>
               <a:spcAft>
-                <a:spcPts val="900"/>
-              </a:spcAft>
-              <a:defRPr sz="1200">
-                <a:solidFill>
-                  <a:srgbClr val="0F172A"/>
-                </a:solidFill>
-              </a:defRPr>
-            </a:pPr>
-            <a:r>
-              <a:t>•  Zero-latency automated polling of GTU portal.</a:t>
-            </a:r>
-          </a:p>
-          <a:p>
-            <a:pPr>
-              <a:spcAft>
-                <a:spcPts val="900"/>
-              </a:spcAft>
-              <a:defRPr sz="1200">
-                <a:solidFill>
-                  <a:srgbClr val="0F172A"/>
-                </a:solidFill>
-              </a:defRPr>
-            </a:pPr>
-            <a:r>
-              <a:t>•  Regex NLP automatically tags stream, sem &amp; exam.</a:t>
-            </a:r>
-          </a:p>
-          <a:p>
-            <a:pPr>
-              <a:spcAft>
-                <a:spcPts val="900"/>
-              </a:spcAft>
-              <a:defRPr sz="1200">
-                <a:solidFill>
-                  <a:srgbClr val="0F172A"/>
-                </a:solidFill>
-              </a:defRPr>
-            </a:pPr>
-            <a:r>
-              <a:t>•  Penalty fee &amp; deadline extractor flag urgent alerts.</a:t>
-            </a:r>
-          </a:p>
-          <a:p>
-            <a:pPr>
-              <a:spcAft>
-                <a:spcPts val="900"/>
-              </a:spcAft>
-              <a:defRPr sz="1200">
-                <a:solidFill>
-                  <a:srgbClr val="0F172A"/>
-                </a:solidFill>
-              </a:defRPr>
-            </a:pPr>
-            <a:r>
-              <a:t>•  30-Sec Daily Voice Bulletin audio briefing (gTTS).</a:t>
-            </a:r>
-          </a:p>
-          <a:p>
-            <a:pPr>
-              <a:spcAft>
-                <a:spcPts val="900"/>
-              </a:spcAft>
-              <a:defRPr sz="1200">
-                <a:solidFill>
-                  <a:srgbClr val="0F172A"/>
-                </a:solidFill>
-              </a:defRPr>
-            </a:pPr>
-            <a:r>
-              <a:t>•  Gemini AI delivers 1-sentence instant takeaways.</a:t>
+                <a:spcPts val="1200"/>
+              </a:spcAft>
+              <a:defRPr sz="1300">
+                <a:solidFill>
+                  <a:srgbClr val="0F172A"/>
+                </a:solidFill>
+              </a:defRPr>
+            </a:pPr>
+            <a:r>
+              <a:t>•  Saad Mansuri</a:t>
+            </a:r>
+          </a:p>
+          <a:p>
+            <a:pPr>
+              <a:spcAft>
+                <a:spcPts val="1200"/>
+              </a:spcAft>
+              <a:defRPr sz="1300">
+                <a:solidFill>
+                  <a:srgbClr val="0F172A"/>
+                </a:solidFill>
+              </a:defRPr>
+            </a:pPr>
+            <a:r>
+              <a:t>•  Zakwan Nawab</a:t>
+            </a:r>
+          </a:p>
+          <a:p>
+            <a:pPr>
+              <a:spcAft>
+                <a:spcPts val="1200"/>
+              </a:spcAft>
+              <a:defRPr sz="1300">
+                <a:solidFill>
+                  <a:srgbClr val="0F172A"/>
+                </a:solidFill>
+              </a:defRPr>
+            </a:pPr>
+            <a:r>
+              <a:t>•  Sunny Gondaliya</a:t>
+            </a:r>
+          </a:p>
+          <a:p>
+            <a:pPr>
+              <a:spcAft>
+                <a:spcPts val="1200"/>
+              </a:spcAft>
+              <a:defRPr sz="1300">
+                <a:solidFill>
+                  <a:srgbClr val="0F172A"/>
+                </a:solidFill>
+              </a:defRPr>
+            </a:pPr>
+            <a:r>
+              <a:t>•  Prit Patel</a:t>
+            </a:r>
+          </a:p>
+          <a:p>
+            <a:pPr>
+              <a:spcAft>
+                <a:spcPts val="1200"/>
+              </a:spcAft>
+              <a:defRPr sz="1300">
+                <a:solidFill>
+                  <a:srgbClr val="0F172A"/>
+                </a:solidFill>
+              </a:defRPr>
+            </a:pPr>
+            <a:r>
+              <a:t>•  Role: Core Developer &amp; NLP Contributor</a:t>
+            </a:r>
+          </a:p>
+          <a:p>
+            <a:pPr>
+              <a:spcAft>
+                <a:spcPts val="1200"/>
+              </a:spcAft>
+              <a:defRPr sz="1300">
+                <a:solidFill>
+                  <a:srgbClr val="0F172A"/>
+                </a:solidFill>
+              </a:defRPr>
+            </a:pPr>
+            <a:r>
+              <a:t>•  Role: Scraping &amp; Notification Engine</a:t>
             </a:r>
           </a:p>
         </p:txBody>
@@ -3761,8 +3830,8 @@
         </p:nvSpPr>
         <p:spPr>
           <a:xfrm>
-            <a:off x="6190488" y="2148840"/>
-            <a:ext cx="2578608" cy="4206240"/>
+            <a:off x="8275320" y="2148840"/>
+            <a:ext cx="3383280" cy="4206240"/>
           </a:xfrm>
           <a:prstGeom prst="roundRect">
             <a:avLst/>
@@ -3806,244 +3875,8 @@
         </p:nvSpPr>
         <p:spPr>
           <a:xfrm>
-            <a:off x="6190488" y="2148840"/>
-            <a:ext cx="2578608" cy="475488"/>
-          </a:xfrm>
-          <a:prstGeom prst="roundRect">
-            <a:avLst/>
-          </a:prstGeom>
-          <a:solidFill>
-            <a:srgbClr val="10B981"/>
-          </a:solidFill>
-          <a:ln>
-            <a:noFill/>
-          </a:ln>
-        </p:spPr>
-        <p:style>
-          <a:lnRef idx="1">
-            <a:schemeClr val="accent1"/>
-          </a:lnRef>
-          <a:fillRef idx="3">
-            <a:schemeClr val="accent1"/>
-          </a:fillRef>
-          <a:effectRef idx="2">
-            <a:schemeClr val="accent1"/>
-          </a:effectRef>
-          <a:fontRef idx="minor">
-            <a:schemeClr val="lt1"/>
-          </a:fontRef>
-        </p:style>
-        <p:txBody>
-          <a:bodyPr rtlCol="0" anchor="ctr"/>
-          <a:lstStyle/>
-          <a:p>
-            <a:pPr algn="ctr"/>
-          </a:p>
-        </p:txBody>
-      </p:sp>
-      <p:sp>
-        <p:nvSpPr>
-          <p:cNvPr id="17" name="TextBox 16"/>
-          <p:cNvSpPr txBox="1"/>
-          <p:nvPr/>
-        </p:nvSpPr>
-        <p:spPr>
-          <a:xfrm>
-            <a:off x="6355080" y="2194560"/>
-            <a:ext cx="2249424" cy="402336"/>
-          </a:xfrm>
-          <a:prstGeom prst="rect">
-            <a:avLst/>
-          </a:prstGeom>
-          <a:noFill/>
-        </p:spPr>
-        <p:txBody>
-          <a:bodyPr wrap="square">
-            <a:spAutoFit/>
-          </a:bodyPr>
-          <a:lstStyle/>
-          <a:p>
-            <a:pPr>
-              <a:defRPr sz="1450" b="1">
-                <a:solidFill>
-                  <a:srgbClr val="FFFFFF"/>
-                </a:solidFill>
-              </a:defRPr>
-            </a:pPr>
-            <a:r>
-              <a:t>Technology Stack</a:t>
-            </a:r>
-          </a:p>
-        </p:txBody>
-      </p:sp>
-      <p:sp>
-        <p:nvSpPr>
-          <p:cNvPr id="18" name="TextBox 17"/>
-          <p:cNvSpPr txBox="1"/>
-          <p:nvPr/>
-        </p:nvSpPr>
-        <p:spPr>
-          <a:xfrm>
-            <a:off x="6355080" y="2697480"/>
-            <a:ext cx="2249424" cy="3602736"/>
-          </a:xfrm>
-          <a:prstGeom prst="rect">
-            <a:avLst/>
-          </a:prstGeom>
-          <a:noFill/>
-        </p:spPr>
-        <p:txBody>
-          <a:bodyPr wrap="square">
-            <a:spAutoFit/>
-          </a:bodyPr>
-          <a:lstStyle/>
-          <a:p>
-            <a:pPr>
-              <a:spcAft>
-                <a:spcPts val="900"/>
-              </a:spcAft>
-              <a:defRPr sz="1200">
-                <a:solidFill>
-                  <a:srgbClr val="0F172A"/>
-                </a:solidFill>
-              </a:defRPr>
-            </a:pPr>
-            <a:r>
-              <a:t>•  Language: Python 3.10+</a:t>
-            </a:r>
-          </a:p>
-          <a:p>
-            <a:pPr>
-              <a:spcAft>
-                <a:spcPts val="900"/>
-              </a:spcAft>
-              <a:defRPr sz="1200">
-                <a:solidFill>
-                  <a:srgbClr val="0F172A"/>
-                </a:solidFill>
-              </a:defRPr>
-            </a:pPr>
-            <a:r>
-              <a:t>•  Web Scraping: BeautifulSoup4 &amp; requests</a:t>
-            </a:r>
-          </a:p>
-          <a:p>
-            <a:pPr>
-              <a:spcAft>
-                <a:spcPts val="900"/>
-              </a:spcAft>
-              <a:defRPr sz="1200">
-                <a:solidFill>
-                  <a:srgbClr val="0F172A"/>
-                </a:solidFill>
-              </a:defRPr>
-            </a:pPr>
-            <a:r>
-              <a:t>•  Database: SQLite (SHA-256 Deduplication)</a:t>
-            </a:r>
-          </a:p>
-          <a:p>
-            <a:pPr>
-              <a:spcAft>
-                <a:spcPts val="900"/>
-              </a:spcAft>
-              <a:defRPr sz="1200">
-                <a:solidFill>
-                  <a:srgbClr val="0F172A"/>
-                </a:solidFill>
-              </a:defRPr>
-            </a:pPr>
-            <a:r>
-              <a:t>•  APIs: Telegram Bot API &amp; Discord Webhook</a:t>
-            </a:r>
-          </a:p>
-          <a:p>
-            <a:pPr>
-              <a:spcAft>
-                <a:spcPts val="900"/>
-              </a:spcAft>
-              <a:defRPr sz="1200">
-                <a:solidFill>
-                  <a:srgbClr val="0F172A"/>
-                </a:solidFill>
-              </a:defRPr>
-            </a:pPr>
-            <a:r>
-              <a:t>•  Frontend: Vanilla JS PWA (Offline Cache)</a:t>
-            </a:r>
-          </a:p>
-          <a:p>
-            <a:pPr>
-              <a:spcAft>
-                <a:spcPts val="900"/>
-              </a:spcAft>
-              <a:defRPr sz="1200">
-                <a:solidFill>
-                  <a:srgbClr val="0F172A"/>
-                </a:solidFill>
-              </a:defRPr>
-            </a:pPr>
-            <a:r>
-              <a:t>•  Automation: GitHub Actions (Zero Cost)</a:t>
-            </a:r>
-          </a:p>
-        </p:txBody>
-      </p:sp>
-      <p:sp>
-        <p:nvSpPr>
-          <p:cNvPr id="19" name="Rounded Rectangle 18"/>
-          <p:cNvSpPr/>
-          <p:nvPr/>
-        </p:nvSpPr>
-        <p:spPr>
-          <a:xfrm>
-            <a:off x="8988552" y="2148840"/>
-            <a:ext cx="2578608" cy="4206240"/>
-          </a:xfrm>
-          <a:prstGeom prst="roundRect">
-            <a:avLst/>
-          </a:prstGeom>
-          <a:solidFill>
-            <a:srgbClr val="FFFFFF"/>
-          </a:solidFill>
-          <a:ln w="19050">
-            <a:solidFill>
-              <a:srgbClr val="CBD5E1"/>
-            </a:solidFill>
-          </a:ln>
-        </p:spPr>
-        <p:style>
-          <a:lnRef idx="1">
-            <a:schemeClr val="accent1"/>
-          </a:lnRef>
-          <a:fillRef idx="3">
-            <a:schemeClr val="accent1"/>
-          </a:fillRef>
-          <a:effectRef idx="2">
-            <a:schemeClr val="accent1"/>
-          </a:effectRef>
-          <a:fontRef idx="minor">
-            <a:schemeClr val="lt1"/>
-          </a:fontRef>
-        </p:style>
-        <p:txBody>
-          <a:bodyPr rtlCol="0" anchor="ctr"/>
-          <a:lstStyle/>
-          <a:p>
-            <a:pPr algn="ctr"/>
-          </a:p>
-        </p:txBody>
-      </p:sp>
-      <p:sp>
-        <p:nvSpPr>
-          <p:cNvPr id="20" name="Rounded Rectangle 19"/>
-          <p:cNvSpPr/>
-          <p:nvPr/>
-        </p:nvSpPr>
-        <p:spPr>
-          <a:xfrm>
-            <a:off x="8988552" y="2148840"/>
-            <a:ext cx="2578608" cy="475488"/>
+            <a:off x="8275320" y="2148840"/>
+            <a:ext cx="3383280" cy="594360"/>
           </a:xfrm>
           <a:prstGeom prst="roundRect">
             <a:avLst/>
@@ -4079,14 +3912,14 @@
       </p:sp>
       <p:sp>
         <p:nvSpPr>
-          <p:cNvPr id="21" name="TextBox 20"/>
+          <p:cNvPr id="17" name="TextBox 16"/>
           <p:cNvSpPr txBox="1"/>
           <p:nvPr/>
         </p:nvSpPr>
         <p:spPr>
           <a:xfrm>
-            <a:off x="9153144" y="2194560"/>
-            <a:ext cx="2249424" cy="402336"/>
+            <a:off x="8439912" y="2194560"/>
+            <a:ext cx="3054096" cy="521208"/>
           </a:xfrm>
           <a:prstGeom prst="rect">
             <a:avLst/>
@@ -4107,21 +3940,33 @@
               </a:defRPr>
             </a:pPr>
             <a:r>
-              <a:t>Team &amp; Institute</a:t>
-            </a:r>
-          </a:p>
-        </p:txBody>
-      </p:sp>
-      <p:sp>
-        <p:nvSpPr>
-          <p:cNvPr id="22" name="TextBox 21"/>
+              <a:t>Team Members (Part 2)</a:t>
+            </a:r>
+          </a:p>
+          <a:p>
+            <a:pPr>
+              <a:defRPr sz="950" b="1">
+                <a:solidFill>
+                  <a:srgbClr val="E0F2FE"/>
+                </a:solidFill>
+              </a:defRPr>
+            </a:pPr>
+            <a:r>
+              <a:t>PROJECT TEAM MEMBERS</a:t>
+            </a:r>
+          </a:p>
+        </p:txBody>
+      </p:sp>
+      <p:sp>
+        <p:nvSpPr>
+          <p:cNvPr id="18" name="TextBox 17"/>
           <p:cNvSpPr txBox="1"/>
           <p:nvPr/>
         </p:nvSpPr>
         <p:spPr>
           <a:xfrm>
-            <a:off x="9153144" y="2697480"/>
-            <a:ext cx="2249424" cy="3602736"/>
+            <a:off x="8439912" y="2816352"/>
+            <a:ext cx="3054096" cy="3483864"/>
           </a:xfrm>
           <a:prstGeom prst="rect">
             <a:avLst/>
@@ -4136,91 +3981,91 @@
           <a:p>
             <a:pPr>
               <a:spcAft>
-                <a:spcPts val="900"/>
-              </a:spcAft>
-              <a:defRPr sz="1200">
-                <a:solidFill>
-                  <a:srgbClr val="0F172A"/>
-                </a:solidFill>
-              </a:defRPr>
-            </a:pPr>
-            <a:r>
-              <a:t>•  Team Name: GTU Innovators</a:t>
-            </a:r>
-          </a:p>
-          <a:p>
-            <a:pPr>
-              <a:spcAft>
-                <a:spcPts val="900"/>
-              </a:spcAft>
-              <a:defRPr sz="1200">
-                <a:solidFill>
-                  <a:srgbClr val="0F172A"/>
-                </a:solidFill>
-              </a:defRPr>
-            </a:pPr>
-            <a:r>
-              <a:t>•  Team Leader: [Your Name]</a:t>
-            </a:r>
-          </a:p>
-          <a:p>
-            <a:pPr>
-              <a:spcAft>
-                <a:spcPts val="900"/>
-              </a:spcAft>
-              <a:defRPr sz="1200">
-                <a:solidFill>
-                  <a:srgbClr val="0F172A"/>
-                </a:solidFill>
-              </a:defRPr>
-            </a:pPr>
-            <a:r>
-              <a:t>•  Members: [Team Member Names]</a:t>
-            </a:r>
-          </a:p>
-          <a:p>
-            <a:pPr>
-              <a:spcAft>
-                <a:spcPts val="900"/>
-              </a:spcAft>
-              <a:defRPr sz="1200">
-                <a:solidFill>
-                  <a:srgbClr val="0F172A"/>
-                </a:solidFill>
-              </a:defRPr>
-            </a:pPr>
-            <a:r>
-              <a:t>•  Department: Computer / IT Engineering</a:t>
-            </a:r>
-          </a:p>
-          <a:p>
-            <a:pPr>
-              <a:spcAft>
-                <a:spcPts val="900"/>
-              </a:spcAft>
-              <a:defRPr sz="1200">
-                <a:solidFill>
-                  <a:srgbClr val="0F172A"/>
-                </a:solidFill>
-              </a:defRPr>
-            </a:pPr>
-            <a:r>
-              <a:t>•  Institute: [Your College Name]</a:t>
-            </a:r>
-          </a:p>
-          <a:p>
-            <a:pPr>
-              <a:spcAft>
-                <a:spcPts val="900"/>
-              </a:spcAft>
-              <a:defRPr sz="1200">
-                <a:solidFill>
-                  <a:srgbClr val="0F172A"/>
-                </a:solidFill>
-              </a:defRPr>
-            </a:pPr>
-            <a:r>
-              <a:t>•  Project Guide: [Faculty / Guide Name]</a:t>
+                <a:spcPts val="1200"/>
+              </a:spcAft>
+              <a:defRPr sz="1300">
+                <a:solidFill>
+                  <a:srgbClr val="0F172A"/>
+                </a:solidFill>
+              </a:defRPr>
+            </a:pPr>
+            <a:r>
+              <a:t>•  Ved Patel</a:t>
+            </a:r>
+          </a:p>
+          <a:p>
+            <a:pPr>
+              <a:spcAft>
+                <a:spcPts val="1200"/>
+              </a:spcAft>
+              <a:defRPr sz="1300">
+                <a:solidFill>
+                  <a:srgbClr val="0F172A"/>
+                </a:solidFill>
+              </a:defRPr>
+            </a:pPr>
+            <a:r>
+              <a:t>•  Shivans Tiwari</a:t>
+            </a:r>
+          </a:p>
+          <a:p>
+            <a:pPr>
+              <a:spcAft>
+                <a:spcPts val="1200"/>
+              </a:spcAft>
+              <a:defRPr sz="1300">
+                <a:solidFill>
+                  <a:srgbClr val="0F172A"/>
+                </a:solidFill>
+              </a:defRPr>
+            </a:pPr>
+            <a:r>
+              <a:t>•  Anmol Varma</a:t>
+            </a:r>
+          </a:p>
+          <a:p>
+            <a:pPr>
+              <a:spcAft>
+                <a:spcPts val="1200"/>
+              </a:spcAft>
+              <a:defRPr sz="1300">
+                <a:solidFill>
+                  <a:srgbClr val="0F172A"/>
+                </a:solidFill>
+              </a:defRPr>
+            </a:pPr>
+            <a:r>
+              <a:t>•  Khushi Gohil</a:t>
+            </a:r>
+          </a:p>
+          <a:p>
+            <a:pPr>
+              <a:spcAft>
+                <a:spcPts val="1200"/>
+              </a:spcAft>
+              <a:defRPr sz="1300">
+                <a:solidFill>
+                  <a:srgbClr val="0F172A"/>
+                </a:solidFill>
+              </a:defRPr>
+            </a:pPr>
+            <a:r>
+              <a:t>•  Role: Web Dashboard &amp; PWA Frontend</a:t>
+            </a:r>
+          </a:p>
+          <a:p>
+            <a:pPr>
+              <a:spcAft>
+                <a:spcPts val="1200"/>
+              </a:spcAft>
+              <a:defRPr sz="1300">
+                <a:solidFill>
+                  <a:srgbClr val="0F172A"/>
+                </a:solidFill>
+              </a:defRPr>
+            </a:pPr>
+            <a:r>
+              <a:t>•  Role: Research, Testing &amp; Quality Assurance</a:t>
             </a:r>
           </a:p>
         </p:txBody>
@@ -5076,7 +4921,7 @@
               </a:defRPr>
             </a:pPr>
             <a:r>
-              <a:t>GTU Automated Alert System  •  Team: GTU Innovators  •  Open-Source &amp; Deployable Today</a:t>
+              <a:t>GTU Automated Alert System  •  Team Leader: Muhammad Sambhyana  •  First Year Engineering Project</a:t>
             </a:r>
           </a:p>
         </p:txBody>

</xml_diff>

<commit_message>
Update department to ICT (Information & Communication Technology)
</commit_message>
<xml_diff>
--- a/PPT_GTU_Alert_System_Presentation.pptx
+++ b/PPT_GTU_Alert_System_Presentation.pptx
@@ -3509,7 +3509,7 @@
               </a:defRPr>
             </a:pPr>
             <a:r>
-              <a:t>•  Department: Computer / IT Engineering</a:t>
+              <a:t>•  Department: ICT (Information &amp; Communication Technology)</a:t>
             </a:r>
           </a:p>
           <a:p>
@@ -4366,7 +4366,7 @@
               </a:defRPr>
             </a:pPr>
             <a:r>
-              <a:t>GTU Circular &amp; Notification Alert System  |  Department of Computer / IT Engineering</a:t>
+              <a:t>GTU Circular &amp; Notification Alert System  |  Department of ICT (Information &amp; Communication Technology)</a:t>
             </a:r>
           </a:p>
         </p:txBody>
@@ -5222,7 +5222,7 @@
               </a:defRPr>
             </a:pPr>
             <a:r>
-              <a:t>GTU Circular &amp; Notification Alert System  |  Department of Computer / IT Engineering</a:t>
+              <a:t>GTU Circular &amp; Notification Alert System  |  Department of ICT (Information &amp; Communication Technology)</a:t>
             </a:r>
           </a:p>
         </p:txBody>
@@ -6302,7 +6302,7 @@
               </a:defRPr>
             </a:pPr>
             <a:r>
-              <a:t>GTU Circular &amp; Notification Alert System  |  Department of Computer / IT Engineering</a:t>
+              <a:t>GTU Circular &amp; Notification Alert System  |  Department of ICT (Information &amp; Communication Technology)</a:t>
             </a:r>
           </a:p>
         </p:txBody>
@@ -7462,7 +7462,7 @@
               </a:defRPr>
             </a:pPr>
             <a:r>
-              <a:t>GTU Circular &amp; Notification Alert System  |  Department of Computer / IT Engineering</a:t>
+              <a:t>GTU Circular &amp; Notification Alert System  |  Department of ICT (Information &amp; Communication Technology)</a:t>
             </a:r>
           </a:p>
         </p:txBody>
@@ -8850,7 +8850,7 @@
               </a:defRPr>
             </a:pPr>
             <a:r>
-              <a:t>GTU Circular &amp; Notification Alert System  |  Department of Computer / IT Engineering</a:t>
+              <a:t>GTU Circular &amp; Notification Alert System  |  Department of ICT (Information &amp; Communication Technology)</a:t>
             </a:r>
           </a:p>
         </p:txBody>
@@ -9787,7 +9787,7 @@
               </a:defRPr>
             </a:pPr>
             <a:r>
-              <a:t>GTU Circular &amp; Notification Alert System  |  Department of Computer / IT Engineering</a:t>
+              <a:t>GTU Circular &amp; Notification Alert System  |  Department of ICT (Information &amp; Communication Technology)</a:t>
             </a:r>
           </a:p>
         </p:txBody>
@@ -10664,7 +10664,7 @@
               </a:defRPr>
             </a:pPr>
             <a:r>
-              <a:t>GTU Circular &amp; Notification Alert System  |  Department of Computer / IT Engineering</a:t>
+              <a:t>GTU Circular &amp; Notification Alert System  |  Department of ICT (Information &amp; Communication Technology)</a:t>
             </a:r>
           </a:p>
         </p:txBody>
@@ -11744,7 +11744,7 @@
               </a:defRPr>
             </a:pPr>
             <a:r>
-              <a:t>GTU Circular &amp; Notification Alert System  |  Department of Computer / IT Engineering</a:t>
+              <a:t>GTU Circular &amp; Notification Alert System  |  Department of ICT (Information &amp; Communication Technology)</a:t>
             </a:r>
           </a:p>
         </p:txBody>
@@ -12779,7 +12779,7 @@
               </a:defRPr>
             </a:pPr>
             <a:r>
-              <a:t>GTU Circular &amp; Notification Alert System  |  Department of Computer / IT Engineering</a:t>
+              <a:t>GTU Circular &amp; Notification Alert System  |  Department of ICT (Information &amp; Communication Technology)</a:t>
             </a:r>
           </a:p>
         </p:txBody>

</xml_diff>